<commit_message>
Correct the divert-code ask and tighten the Truecaller citation
The ask named *21, which is the GSMA activation prefix, not the gate we want. Grameenphone's own
Useful Information page publishes ##002# to cancel all forwarding and *#21# to read its status, so
slide 10 now asks for a divert-gating test on those.

Truecaller's 4M+ paying subscribers and 0.75% average conversion come from its 10 March 2026 release
covering Q4 2025 — first-party newsroom rather than the wire copy, and labelled global, because it
evidences willingness to pay for caller safety rather than demand among Grameenphone subscribers.

render-pptx.py: clean over 216 text blocks.
</commit_message>
<xml_diff>
--- a/pitch/Shotorko-GP-FutureMakers-2026.pptx
+++ b/pitch/Shotorko-GP-FutureMakers-2026.pptx
@@ -4105,7 +4105,7 @@
                 <a:ea typeface="Segoe UI"/>
                 <a:cs typeface="Segoe UI"/>
               </a:rPr>
-              <a:t>one USSD gating test on *21</a:t>
+              <a:t>one divert-gating test: ##002# erasure, *#21# status</a:t>
             </a:r>
           </a:p>
         </p:txBody>
@@ -5213,7 +5213,7 @@
                 <a:ea typeface="Segoe UI"/>
                 <a:cs typeface="Segoe UI"/>
               </a:rPr>
-              <a:t>Truecaller AB, 10 March 2026 — news.cision.com/truecaller-ab/r/truecaller-surpasses-4-million-premium-subscribers,c4318816</a:t>
+              <a:t>Truecaller AB, 10 March 2026 (global, Q4 2025 figures) — corporate.truecaller.com/newsroom/press-release/truecaller-surpasses-4-million-premium-subscribers</a:t>
             </a:r>
           </a:p>
         </p:txBody>
@@ -17444,7 +17444,7 @@
                 <a:ea typeface="Segoe UI"/>
                 <a:cs typeface="Segoe UI"/>
               </a:rPr>
-              <a:t>Truecaller: 4M+ paying subscribers, 0.75% of free users convert (Mar 2026)</a:t>
+              <a:t>Truecaller: 4M+ paying subscribers, 0.75% convert — global, not Bangladeshi</a:t>
             </a:r>
           </a:p>
         </p:txBody>

</xml_diff>

<commit_message>
Add the presenter brief and stop claiming an unverifiable month
The slides were submitted, so the remaining risk is answering questions about
them. The Bangladesh Bank rows are now cited by table number rather than by a
month this machine cannot re-fetch, and dev/build-brief.py assembles a single
study document from the built .pptx, the deck markdown and the engine source:
how the prototype works, what the backend guarantees, every number with its
status, each slide with what to say and the trap to avoid, and the honest
limits to volunteer first.
</commit_message>
<xml_diff>
--- a/pitch/Shotorko-GP-FutureMakers-2026.pptx
+++ b/pitch/Shotorko-GP-FutureMakers-2026.pptx
@@ -11612,7 +11612,7 @@
                 <a:ea typeface="Segoe UI"/>
                 <a:cs typeface="Segoe UI"/>
               </a:rPr>
-              <a:t>MOBILE FINANCIAL SERVICES — BANGLADESH BANK, JULY 2026  ·  SUBSCRIBERS — BTRC, AUGUST 2026</a:t>
+              <a:t>MOBILE FINANCIAL SERVICES — BANGLADESH BANK, TABLES 9 AND 8  ·  SUBSCRIBERS — BTRC, AUGUST 2026</a:t>
             </a:r>
           </a:p>
         </p:txBody>
@@ -18703,7 +18703,7 @@
                 <a:ea typeface="Segoe UI"/>
                 <a:cs typeface="Segoe UI"/>
               </a:rPr>
-              <a:t>Denominators: BTRC subscribers (Aug 2026), Bangladesh Bank MFS (Jul 2026). The Tk 20 price and the 1% attach rate are our assumptions, not a surveyed willingness to pay.</a:t>
+              <a:t>Denominators: BTRC subscribers (Aug 2026), Bangladesh Bank MFS Tables 9 and 8. The Tk 20 price and the 1% attach rate are our assumptions, not a surveyed willingness to pay.</a:t>
             </a:r>
           </a:p>
         </p:txBody>

</xml_diff>